<commit_message>
fix(high): moved 0 coordinate of time in the 3rd problem
</commit_message>
<xml_diff>
--- a/high/piecewise-functions/piecewise-functions-problems.pptx
+++ b/high/piecewise-functions/piecewise-functions-problems.pptx
@@ -1675,6 +1675,47 @@
         </p:nvSpPr>
         <p:spPr>
           <a:xfrm>
+            <a:off x="6766560" y="54864"/>
+            <a:ext cx="2286000" cy="274320"/>
+          </a:xfrm>
+          <a:prstGeom prst="rect">
+            <a:avLst/>
+          </a:prstGeom>
+          <a:noFill/>
+          <a:ln/>
+        </p:spPr>
+        <p:txBody>
+          <a:bodyPr wrap="square" lIns="0" tIns="0" rIns="0" bIns="0" rtlCol="0" anchor="t"/>
+          <a:lstStyle/>
+          <a:p>
+            <a:pPr algn="r" indent="0" marL="0">
+              <a:buNone/>
+            </a:pPr>
+            <a:r>
+              <a:rPr lang="en-US" sz="1000" dirty="0">
+                <a:solidFill>
+                  <a:srgbClr val="CADCFC">
+                    <a:alpha val="75000"/>
+                  </a:srgbClr>
+                </a:solidFill>
+                <a:latin typeface="Consolas" pitchFamily="34" charset="0"/>
+                <a:ea typeface="Consolas" pitchFamily="34" charset="-122"/>
+                <a:cs typeface="Consolas" pitchFamily="34" charset="-120"/>
+              </a:rPr>
+              <a:t>github.com://dzh-a-v</a:t>
+            </a:r>
+            <a:endParaRPr lang="en-US" sz="1000" dirty="0"/>
+          </a:p>
+        </p:txBody>
+      </p:sp>
+      <p:sp>
+        <p:nvSpPr>
+          <p:cNvPr id="8" name="Text 6"/>
+          <p:cNvSpPr/>
+          <p:nvPr/>
+        </p:nvSpPr>
+        <p:spPr>
+          <a:xfrm>
             <a:off x="457200" y="1143000"/>
             <a:ext cx="5212080" cy="457200"/>
           </a:xfrm>
@@ -1708,7 +1749,7 @@
       </p:sp>
       <p:sp>
         <p:nvSpPr>
-          <p:cNvPr id="8" name="Text 6"/>
+          <p:cNvPr id="9" name="Text 7"/>
           <p:cNvSpPr/>
           <p:nvPr/>
         </p:nvSpPr>
@@ -1772,7 +1813,7 @@
       </p:sp>
       <p:sp>
         <p:nvSpPr>
-          <p:cNvPr id="9" name="Shape 7"/>
+          <p:cNvPr id="10" name="Shape 8"/>
           <p:cNvSpPr/>
           <p:nvPr/>
         </p:nvSpPr>
@@ -1797,7 +1838,7 @@
       </p:sp>
       <p:sp>
         <p:nvSpPr>
-          <p:cNvPr id="10" name="Text 8"/>
+          <p:cNvPr id="11" name="Text 9"/>
           <p:cNvSpPr/>
           <p:nvPr/>
         </p:nvSpPr>
@@ -1836,7 +1877,7 @@
       </p:sp>
       <p:sp>
         <p:nvSpPr>
-          <p:cNvPr id="11" name="Text 9"/>
+          <p:cNvPr id="12" name="Text 10"/>
           <p:cNvSpPr/>
           <p:nvPr/>
         </p:nvSpPr>
@@ -1898,7 +1939,7 @@
       </p:sp>
       <p:sp>
         <p:nvSpPr>
-          <p:cNvPr id="12" name="Text 10"/>
+          <p:cNvPr id="13" name="Text 11"/>
           <p:cNvSpPr/>
           <p:nvPr/>
         </p:nvSpPr>
@@ -1960,7 +2001,7 @@
       </p:sp>
       <p:sp>
         <p:nvSpPr>
-          <p:cNvPr id="13" name="Shape 11"/>
+          <p:cNvPr id="14" name="Shape 12"/>
           <p:cNvSpPr/>
           <p:nvPr/>
         </p:nvSpPr>
@@ -1985,7 +2026,7 @@
       </p:sp>
       <p:sp>
         <p:nvSpPr>
-          <p:cNvPr id="14" name="Text 12"/>
+          <p:cNvPr id="15" name="Text 13"/>
           <p:cNvSpPr/>
           <p:nvPr/>
         </p:nvSpPr>
@@ -2024,7 +2065,7 @@
       </p:sp>
       <p:sp>
         <p:nvSpPr>
-          <p:cNvPr id="15" name="Text 13"/>
+          <p:cNvPr id="16" name="Text 14"/>
           <p:cNvSpPr/>
           <p:nvPr/>
         </p:nvSpPr>
@@ -2126,7 +2167,7 @@
       </p:sp>
       <p:sp>
         <p:nvSpPr>
-          <p:cNvPr id="16" name="Text 14"/>
+          <p:cNvPr id="17" name="Text 15"/>
           <p:cNvSpPr/>
           <p:nvPr/>
         </p:nvSpPr>
@@ -2333,6 +2374,47 @@
         </p:nvSpPr>
         <p:spPr>
           <a:xfrm>
+            <a:off x="6766560" y="54864"/>
+            <a:ext cx="2286000" cy="274320"/>
+          </a:xfrm>
+          <a:prstGeom prst="rect">
+            <a:avLst/>
+          </a:prstGeom>
+          <a:noFill/>
+          <a:ln/>
+        </p:spPr>
+        <p:txBody>
+          <a:bodyPr wrap="square" lIns="0" tIns="0" rIns="0" bIns="0" rtlCol="0" anchor="t"/>
+          <a:lstStyle/>
+          <a:p>
+            <a:pPr algn="r" indent="0" marL="0">
+              <a:buNone/>
+            </a:pPr>
+            <a:r>
+              <a:rPr lang="en-US" sz="1000" dirty="0">
+                <a:solidFill>
+                  <a:srgbClr val="CADCFC">
+                    <a:alpha val="75000"/>
+                  </a:srgbClr>
+                </a:solidFill>
+                <a:latin typeface="Consolas" pitchFamily="34" charset="0"/>
+                <a:ea typeface="Consolas" pitchFamily="34" charset="-122"/>
+                <a:cs typeface="Consolas" pitchFamily="34" charset="-120"/>
+              </a:rPr>
+              <a:t>github.com://dzh-a-v</a:t>
+            </a:r>
+            <a:endParaRPr lang="en-US" sz="1000" dirty="0"/>
+          </a:p>
+        </p:txBody>
+      </p:sp>
+      <p:sp>
+        <p:nvSpPr>
+          <p:cNvPr id="7" name="Text 5"/>
+          <p:cNvSpPr/>
+          <p:nvPr/>
+        </p:nvSpPr>
+        <p:spPr>
+          <a:xfrm>
             <a:off x="457200" y="1097280"/>
             <a:ext cx="5120640" cy="411480"/>
           </a:xfrm>
@@ -2366,7 +2448,7 @@
       </p:sp>
       <p:sp>
         <p:nvSpPr>
-          <p:cNvPr id="7" name="Text 5"/>
+          <p:cNvPr id="8" name="Text 6"/>
           <p:cNvSpPr/>
           <p:nvPr/>
         </p:nvSpPr>
@@ -2575,7 +2657,7 @@
       </p:sp>
       <p:pic>
         <p:nvPicPr>
-          <p:cNvPr id="8" name="Image 0" descr="/home/claude/piecewise/graph1.png">    </p:cNvPr>
+          <p:cNvPr id="9" name="Image 0" descr="/home/claude/piecewise/graph1.png">    </p:cNvPr>
           <p:cNvPicPr>
             <a:picLocks noChangeAspect="1"/>
           </p:cNvPicPr>
@@ -2599,7 +2681,7 @@
       </p:pic>
       <p:sp>
         <p:nvSpPr>
-          <p:cNvPr id="9" name="Shape 6"/>
+          <p:cNvPr id="10" name="Shape 7"/>
           <p:cNvSpPr/>
           <p:nvPr/>
         </p:nvSpPr>
@@ -2624,7 +2706,7 @@
       </p:sp>
       <p:sp>
         <p:nvSpPr>
-          <p:cNvPr id="10" name="Text 7"/>
+          <p:cNvPr id="11" name="Text 8"/>
           <p:cNvSpPr/>
           <p:nvPr/>
         </p:nvSpPr>
@@ -2677,7 +2759,7 @@
       </p:sp>
       <p:sp>
         <p:nvSpPr>
-          <p:cNvPr id="11" name="Text 8"/>
+          <p:cNvPr id="12" name="Text 9"/>
           <p:cNvSpPr/>
           <p:nvPr/>
         </p:nvSpPr>
@@ -2923,6 +3005,47 @@
         </p:nvSpPr>
         <p:spPr>
           <a:xfrm>
+            <a:off x="6766560" y="54864"/>
+            <a:ext cx="2286000" cy="274320"/>
+          </a:xfrm>
+          <a:prstGeom prst="rect">
+            <a:avLst/>
+          </a:prstGeom>
+          <a:noFill/>
+          <a:ln/>
+        </p:spPr>
+        <p:txBody>
+          <a:bodyPr wrap="square" lIns="0" tIns="0" rIns="0" bIns="0" rtlCol="0" anchor="t"/>
+          <a:lstStyle/>
+          <a:p>
+            <a:pPr algn="r" indent="0" marL="0">
+              <a:buNone/>
+            </a:pPr>
+            <a:r>
+              <a:rPr lang="en-US" sz="1000" dirty="0">
+                <a:solidFill>
+                  <a:srgbClr val="CADCFC">
+                    <a:alpha val="75000"/>
+                  </a:srgbClr>
+                </a:solidFill>
+                <a:latin typeface="Consolas" pitchFamily="34" charset="0"/>
+                <a:ea typeface="Consolas" pitchFamily="34" charset="-122"/>
+                <a:cs typeface="Consolas" pitchFamily="34" charset="-120"/>
+              </a:rPr>
+              <a:t>github.com://dzh-a-v</a:t>
+            </a:r>
+            <a:endParaRPr lang="en-US" sz="1000" dirty="0"/>
+          </a:p>
+        </p:txBody>
+      </p:sp>
+      <p:sp>
+        <p:nvSpPr>
+          <p:cNvPr id="8" name="Text 6"/>
+          <p:cNvSpPr/>
+          <p:nvPr/>
+        </p:nvSpPr>
+        <p:spPr>
+          <a:xfrm>
             <a:off x="457200" y="1143000"/>
             <a:ext cx="8229600" cy="411480"/>
           </a:xfrm>
@@ -2956,7 +3079,7 @@
       </p:sp>
       <p:sp>
         <p:nvSpPr>
-          <p:cNvPr id="8" name="Shape 6"/>
+          <p:cNvPr id="9" name="Shape 7"/>
           <p:cNvSpPr/>
           <p:nvPr/>
         </p:nvSpPr>
@@ -2981,7 +3104,7 @@
       </p:sp>
       <p:sp>
         <p:nvSpPr>
-          <p:cNvPr id="9" name="Text 7"/>
+          <p:cNvPr id="10" name="Text 8"/>
           <p:cNvSpPr/>
           <p:nvPr/>
         </p:nvSpPr>
@@ -3020,7 +3143,7 @@
       </p:sp>
       <p:sp>
         <p:nvSpPr>
-          <p:cNvPr id="10" name="Text 8"/>
+          <p:cNvPr id="11" name="Text 9"/>
           <p:cNvSpPr/>
           <p:nvPr/>
         </p:nvSpPr>
@@ -3082,7 +3205,7 @@
       </p:sp>
       <p:sp>
         <p:nvSpPr>
-          <p:cNvPr id="11" name="Text 9"/>
+          <p:cNvPr id="12" name="Text 10"/>
           <p:cNvSpPr/>
           <p:nvPr/>
         </p:nvSpPr>
@@ -3144,7 +3267,7 @@
       </p:sp>
       <p:sp>
         <p:nvSpPr>
-          <p:cNvPr id="12" name="Shape 10"/>
+          <p:cNvPr id="13" name="Shape 11"/>
           <p:cNvSpPr/>
           <p:nvPr/>
         </p:nvSpPr>
@@ -3169,7 +3292,7 @@
       </p:sp>
       <p:sp>
         <p:nvSpPr>
-          <p:cNvPr id="13" name="Text 11"/>
+          <p:cNvPr id="14" name="Text 12"/>
           <p:cNvSpPr/>
           <p:nvPr/>
         </p:nvSpPr>
@@ -3208,7 +3331,7 @@
       </p:sp>
       <p:sp>
         <p:nvSpPr>
-          <p:cNvPr id="14" name="Text 12"/>
+          <p:cNvPr id="15" name="Text 13"/>
           <p:cNvSpPr/>
           <p:nvPr/>
         </p:nvSpPr>
@@ -3247,7 +3370,7 @@
       </p:sp>
       <p:sp>
         <p:nvSpPr>
-          <p:cNvPr id="15" name="Shape 13"/>
+          <p:cNvPr id="16" name="Shape 14"/>
           <p:cNvSpPr/>
           <p:nvPr/>
         </p:nvSpPr>
@@ -3272,7 +3395,7 @@
       </p:sp>
       <p:sp>
         <p:nvSpPr>
-          <p:cNvPr id="16" name="Text 14"/>
+          <p:cNvPr id="17" name="Text 15"/>
           <p:cNvSpPr/>
           <p:nvPr/>
         </p:nvSpPr>
@@ -3311,7 +3434,7 @@
       </p:sp>
       <p:sp>
         <p:nvSpPr>
-          <p:cNvPr id="17" name="Text 15"/>
+          <p:cNvPr id="18" name="Text 16"/>
           <p:cNvSpPr/>
           <p:nvPr/>
         </p:nvSpPr>
@@ -3350,7 +3473,7 @@
       </p:sp>
       <p:sp>
         <p:nvSpPr>
-          <p:cNvPr id="18" name="Shape 16"/>
+          <p:cNvPr id="19" name="Shape 17"/>
           <p:cNvSpPr/>
           <p:nvPr/>
         </p:nvSpPr>
@@ -3375,7 +3498,7 @@
       </p:sp>
       <p:sp>
         <p:nvSpPr>
-          <p:cNvPr id="19" name="Text 17"/>
+          <p:cNvPr id="20" name="Text 18"/>
           <p:cNvSpPr/>
           <p:nvPr/>
         </p:nvSpPr>
@@ -3414,7 +3537,7 @@
       </p:sp>
       <p:sp>
         <p:nvSpPr>
-          <p:cNvPr id="20" name="Text 18"/>
+          <p:cNvPr id="21" name="Text 19"/>
           <p:cNvSpPr/>
           <p:nvPr/>
         </p:nvSpPr>
@@ -3453,7 +3576,7 @@
       </p:sp>
       <p:sp>
         <p:nvSpPr>
-          <p:cNvPr id="21" name="Text 19"/>
+          <p:cNvPr id="22" name="Text 20"/>
           <p:cNvSpPr/>
           <p:nvPr/>
         </p:nvSpPr>
@@ -3660,6 +3783,47 @@
         </p:nvSpPr>
         <p:spPr>
           <a:xfrm>
+            <a:off x="6766560" y="54864"/>
+            <a:ext cx="2286000" cy="274320"/>
+          </a:xfrm>
+          <a:prstGeom prst="rect">
+            <a:avLst/>
+          </a:prstGeom>
+          <a:noFill/>
+          <a:ln/>
+        </p:spPr>
+        <p:txBody>
+          <a:bodyPr wrap="square" lIns="0" tIns="0" rIns="0" bIns="0" rtlCol="0" anchor="t"/>
+          <a:lstStyle/>
+          <a:p>
+            <a:pPr algn="r" indent="0" marL="0">
+              <a:buNone/>
+            </a:pPr>
+            <a:r>
+              <a:rPr lang="en-US" sz="1000" dirty="0">
+                <a:solidFill>
+                  <a:srgbClr val="CADCFC">
+                    <a:alpha val="75000"/>
+                  </a:srgbClr>
+                </a:solidFill>
+                <a:latin typeface="Consolas" pitchFamily="34" charset="0"/>
+                <a:ea typeface="Consolas" pitchFamily="34" charset="-122"/>
+                <a:cs typeface="Consolas" pitchFamily="34" charset="-120"/>
+              </a:rPr>
+              <a:t>github.com://dzh-a-v</a:t>
+            </a:r>
+            <a:endParaRPr lang="en-US" sz="1000" dirty="0"/>
+          </a:p>
+        </p:txBody>
+      </p:sp>
+      <p:sp>
+        <p:nvSpPr>
+          <p:cNvPr id="7" name="Text 5"/>
+          <p:cNvSpPr/>
+          <p:nvPr/>
+        </p:nvSpPr>
+        <p:spPr>
+          <a:xfrm>
             <a:off x="457200" y="1051560"/>
             <a:ext cx="5074920" cy="3611880"/>
           </a:xfrm>
@@ -3880,7 +4044,7 @@
       </p:sp>
       <p:pic>
         <p:nvPicPr>
-          <p:cNvPr id="7" name="Image 0" descr="/home/claude/piecewise/graph2.png">    </p:cNvPr>
+          <p:cNvPr id="8" name="Image 0" descr="/home/claude/piecewise/graph2.png">    </p:cNvPr>
           <p:cNvPicPr>
             <a:picLocks noChangeAspect="1"/>
           </p:cNvPicPr>
@@ -3904,7 +4068,7 @@
       </p:pic>
       <p:sp>
         <p:nvSpPr>
-          <p:cNvPr id="8" name="Shape 5"/>
+          <p:cNvPr id="9" name="Shape 6"/>
           <p:cNvSpPr/>
           <p:nvPr/>
         </p:nvSpPr>
@@ -3929,7 +4093,7 @@
       </p:sp>
       <p:sp>
         <p:nvSpPr>
-          <p:cNvPr id="9" name="Text 6"/>
+          <p:cNvPr id="10" name="Text 7"/>
           <p:cNvSpPr/>
           <p:nvPr/>
         </p:nvSpPr>
@@ -3982,7 +4146,7 @@
       </p:sp>
       <p:sp>
         <p:nvSpPr>
-          <p:cNvPr id="10" name="Text 7"/>
+          <p:cNvPr id="11" name="Text 8"/>
           <p:cNvSpPr/>
           <p:nvPr/>
         </p:nvSpPr>
@@ -4228,6 +4392,47 @@
         </p:nvSpPr>
         <p:spPr>
           <a:xfrm>
+            <a:off x="6766560" y="54864"/>
+            <a:ext cx="2286000" cy="274320"/>
+          </a:xfrm>
+          <a:prstGeom prst="rect">
+            <a:avLst/>
+          </a:prstGeom>
+          <a:noFill/>
+          <a:ln/>
+        </p:spPr>
+        <p:txBody>
+          <a:bodyPr wrap="square" lIns="0" tIns="0" rIns="0" bIns="0" rtlCol="0" anchor="t"/>
+          <a:lstStyle/>
+          <a:p>
+            <a:pPr algn="r" indent="0" marL="0">
+              <a:buNone/>
+            </a:pPr>
+            <a:r>
+              <a:rPr lang="en-US" sz="1000" dirty="0">
+                <a:solidFill>
+                  <a:srgbClr val="CADCFC">
+                    <a:alpha val="75000"/>
+                  </a:srgbClr>
+                </a:solidFill>
+                <a:latin typeface="Consolas" pitchFamily="34" charset="0"/>
+                <a:ea typeface="Consolas" pitchFamily="34" charset="-122"/>
+                <a:cs typeface="Consolas" pitchFamily="34" charset="-120"/>
+              </a:rPr>
+              <a:t>github.com://dzh-a-v</a:t>
+            </a:r>
+            <a:endParaRPr lang="en-US" sz="1000" dirty="0"/>
+          </a:p>
+        </p:txBody>
+      </p:sp>
+      <p:sp>
+        <p:nvSpPr>
+          <p:cNvPr id="8" name="Text 6"/>
+          <p:cNvSpPr/>
+          <p:nvPr/>
+        </p:nvSpPr>
+        <p:spPr>
+          <a:xfrm>
             <a:off x="457200" y="1143000"/>
             <a:ext cx="8229600" cy="411480"/>
           </a:xfrm>
@@ -4261,7 +4466,7 @@
       </p:sp>
       <p:sp>
         <p:nvSpPr>
-          <p:cNvPr id="8" name="Text 6"/>
+          <p:cNvPr id="9" name="Text 7"/>
           <p:cNvSpPr/>
           <p:nvPr/>
         </p:nvSpPr>
@@ -4346,7 +4551,7 @@
       </p:sp>
       <p:sp>
         <p:nvSpPr>
-          <p:cNvPr id="9" name="Shape 7"/>
+          <p:cNvPr id="10" name="Shape 8"/>
           <p:cNvSpPr/>
           <p:nvPr/>
         </p:nvSpPr>
@@ -4371,7 +4576,7 @@
       </p:sp>
       <p:sp>
         <p:nvSpPr>
-          <p:cNvPr id="10" name="Text 8"/>
+          <p:cNvPr id="11" name="Text 9"/>
           <p:cNvSpPr/>
           <p:nvPr/>
         </p:nvSpPr>
@@ -4410,7 +4615,7 @@
       </p:sp>
       <p:sp>
         <p:nvSpPr>
-          <p:cNvPr id="11" name="Text 9"/>
+          <p:cNvPr id="12" name="Text 10"/>
           <p:cNvSpPr/>
           <p:nvPr/>
         </p:nvSpPr>
@@ -4517,7 +4722,7 @@
       </p:sp>
       <p:sp>
         <p:nvSpPr>
-          <p:cNvPr id="12" name="Text 10"/>
+          <p:cNvPr id="13" name="Text 11"/>
           <p:cNvSpPr/>
           <p:nvPr/>
         </p:nvSpPr>
@@ -4570,7 +4775,7 @@
       </p:sp>
       <p:sp>
         <p:nvSpPr>
-          <p:cNvPr id="13" name="Text 11"/>
+          <p:cNvPr id="14" name="Text 12"/>
           <p:cNvSpPr/>
           <p:nvPr/>
         </p:nvSpPr>
@@ -4777,6 +4982,47 @@
         </p:nvSpPr>
         <p:spPr>
           <a:xfrm>
+            <a:off x="6766560" y="54864"/>
+            <a:ext cx="2286000" cy="274320"/>
+          </a:xfrm>
+          <a:prstGeom prst="rect">
+            <a:avLst/>
+          </a:prstGeom>
+          <a:noFill/>
+          <a:ln/>
+        </p:spPr>
+        <p:txBody>
+          <a:bodyPr wrap="square" lIns="0" tIns="0" rIns="0" bIns="0" rtlCol="0" anchor="t"/>
+          <a:lstStyle/>
+          <a:p>
+            <a:pPr algn="r" indent="0" marL="0">
+              <a:buNone/>
+            </a:pPr>
+            <a:r>
+              <a:rPr lang="en-US" sz="1000" dirty="0">
+                <a:solidFill>
+                  <a:srgbClr val="CADCFC">
+                    <a:alpha val="75000"/>
+                  </a:srgbClr>
+                </a:solidFill>
+                <a:latin typeface="Consolas" pitchFamily="34" charset="0"/>
+                <a:ea typeface="Consolas" pitchFamily="34" charset="-122"/>
+                <a:cs typeface="Consolas" pitchFamily="34" charset="-120"/>
+              </a:rPr>
+              <a:t>github.com://dzh-a-v</a:t>
+            </a:r>
+            <a:endParaRPr lang="en-US" sz="1000" dirty="0"/>
+          </a:p>
+        </p:txBody>
+      </p:sp>
+      <p:sp>
+        <p:nvSpPr>
+          <p:cNvPr id="7" name="Text 5"/>
+          <p:cNvSpPr/>
+          <p:nvPr/>
+        </p:nvSpPr>
+        <p:spPr>
+          <a:xfrm>
             <a:off x="457200" y="1051560"/>
             <a:ext cx="5029200" cy="292608"/>
           </a:xfrm>
@@ -4810,7 +5056,7 @@
       </p:sp>
       <p:sp>
         <p:nvSpPr>
-          <p:cNvPr id="7" name="Shape 5"/>
+          <p:cNvPr id="8" name="Shape 6"/>
           <p:cNvSpPr/>
           <p:nvPr/>
         </p:nvSpPr>
@@ -4835,7 +5081,7 @@
       </p:sp>
       <p:sp>
         <p:nvSpPr>
-          <p:cNvPr id="8" name="Text 6"/>
+          <p:cNvPr id="9" name="Text 7"/>
           <p:cNvSpPr/>
           <p:nvPr/>
         </p:nvSpPr>
@@ -4957,7 +5203,7 @@
       </p:sp>
       <p:sp>
         <p:nvSpPr>
-          <p:cNvPr id="9" name="Text 7"/>
+          <p:cNvPr id="10" name="Text 8"/>
           <p:cNvSpPr/>
           <p:nvPr/>
         </p:nvSpPr>
@@ -5079,7 +5325,7 @@
       </p:sp>
       <p:sp>
         <p:nvSpPr>
-          <p:cNvPr id="10" name="Text 8"/>
+          <p:cNvPr id="11" name="Text 9"/>
           <p:cNvSpPr/>
           <p:nvPr/>
         </p:nvSpPr>
@@ -5118,7 +5364,7 @@
       </p:sp>
       <p:sp>
         <p:nvSpPr>
-          <p:cNvPr id="11" name="Text 9"/>
+          <p:cNvPr id="12" name="Text 10"/>
           <p:cNvSpPr/>
           <p:nvPr/>
         </p:nvSpPr>
@@ -5260,7 +5506,7 @@
       </p:sp>
       <p:pic>
         <p:nvPicPr>
-          <p:cNvPr id="12" name="Image 0" descr="/home/claude/piecewise/graph3.png">    </p:cNvPr>
+          <p:cNvPr id="13" name="Image 0" descr="/home/claude/piecewise/graph3.png">    </p:cNvPr>
           <p:cNvPicPr>
             <a:picLocks noChangeAspect="1"/>
           </p:cNvPicPr>
@@ -5284,7 +5530,7 @@
       </p:pic>
       <p:sp>
         <p:nvSpPr>
-          <p:cNvPr id="13" name="Shape 10"/>
+          <p:cNvPr id="14" name="Shape 11"/>
           <p:cNvSpPr/>
           <p:nvPr/>
         </p:nvSpPr>
@@ -5309,7 +5555,7 @@
       </p:sp>
       <p:sp>
         <p:nvSpPr>
-          <p:cNvPr id="14" name="Text 11"/>
+          <p:cNvPr id="15" name="Text 12"/>
           <p:cNvSpPr/>
           <p:nvPr/>
         </p:nvSpPr>
@@ -5362,7 +5608,7 @@
       </p:sp>
       <p:sp>
         <p:nvSpPr>
-          <p:cNvPr id="15" name="Text 12"/>
+          <p:cNvPr id="16" name="Text 13"/>
           <p:cNvSpPr/>
           <p:nvPr/>
         </p:nvSpPr>
@@ -5608,6 +5854,47 @@
         </p:nvSpPr>
         <p:spPr>
           <a:xfrm>
+            <a:off x="6766560" y="54864"/>
+            <a:ext cx="2286000" cy="274320"/>
+          </a:xfrm>
+          <a:prstGeom prst="rect">
+            <a:avLst/>
+          </a:prstGeom>
+          <a:noFill/>
+          <a:ln/>
+        </p:spPr>
+        <p:txBody>
+          <a:bodyPr wrap="square" lIns="0" tIns="0" rIns="0" bIns="0" rtlCol="0" anchor="t"/>
+          <a:lstStyle/>
+          <a:p>
+            <a:pPr algn="r" indent="0" marL="0">
+              <a:buNone/>
+            </a:pPr>
+            <a:r>
+              <a:rPr lang="en-US" sz="1000" dirty="0">
+                <a:solidFill>
+                  <a:srgbClr val="CADCFC">
+                    <a:alpha val="75000"/>
+                  </a:srgbClr>
+                </a:solidFill>
+                <a:latin typeface="Consolas" pitchFamily="34" charset="0"/>
+                <a:ea typeface="Consolas" pitchFamily="34" charset="-122"/>
+                <a:cs typeface="Consolas" pitchFamily="34" charset="-120"/>
+              </a:rPr>
+              <a:t>github.com://dzh-a-v</a:t>
+            </a:r>
+            <a:endParaRPr lang="en-US" sz="1000" dirty="0"/>
+          </a:p>
+        </p:txBody>
+      </p:sp>
+      <p:sp>
+        <p:nvSpPr>
+          <p:cNvPr id="8" name="Text 6"/>
+          <p:cNvSpPr/>
+          <p:nvPr/>
+        </p:nvSpPr>
+        <p:spPr>
+          <a:xfrm>
             <a:off x="457200" y="1143000"/>
             <a:ext cx="8229600" cy="365760"/>
           </a:xfrm>
@@ -5641,7 +5928,7 @@
       </p:sp>
       <p:sp>
         <p:nvSpPr>
-          <p:cNvPr id="8" name="Shape 6"/>
+          <p:cNvPr id="9" name="Shape 7"/>
           <p:cNvSpPr/>
           <p:nvPr/>
         </p:nvSpPr>
@@ -5666,7 +5953,7 @@
       </p:sp>
       <p:sp>
         <p:nvSpPr>
-          <p:cNvPr id="9" name="Text 7"/>
+          <p:cNvPr id="10" name="Text 8"/>
           <p:cNvSpPr/>
           <p:nvPr/>
         </p:nvSpPr>
@@ -5705,7 +5992,7 @@
       </p:sp>
       <p:sp>
         <p:nvSpPr>
-          <p:cNvPr id="10" name="Shape 8"/>
+          <p:cNvPr id="11" name="Shape 9"/>
           <p:cNvSpPr/>
           <p:nvPr/>
         </p:nvSpPr>
@@ -5728,7 +6015,7 @@
       </p:sp>
       <p:sp>
         <p:nvSpPr>
-          <p:cNvPr id="11" name="Shape 9"/>
+          <p:cNvPr id="12" name="Shape 10"/>
           <p:cNvSpPr/>
           <p:nvPr/>
         </p:nvSpPr>
@@ -5751,7 +6038,7 @@
       </p:sp>
       <p:sp>
         <p:nvSpPr>
-          <p:cNvPr id="12" name="Shape 10"/>
+          <p:cNvPr id="13" name="Shape 11"/>
           <p:cNvSpPr/>
           <p:nvPr/>
         </p:nvSpPr>
@@ -5774,7 +6061,7 @@
       </p:sp>
       <p:sp>
         <p:nvSpPr>
-          <p:cNvPr id="13" name="Text 11"/>
+          <p:cNvPr id="14" name="Text 12"/>
           <p:cNvSpPr/>
           <p:nvPr/>
         </p:nvSpPr>
@@ -5856,7 +6143,7 @@
       </p:sp>
       <p:sp>
         <p:nvSpPr>
-          <p:cNvPr id="14" name="Text 12"/>
+          <p:cNvPr id="15" name="Text 13"/>
           <p:cNvSpPr/>
           <p:nvPr/>
         </p:nvSpPr>
@@ -5938,7 +6225,7 @@
       </p:sp>
       <p:sp>
         <p:nvSpPr>
-          <p:cNvPr id="15" name="Shape 13"/>
+          <p:cNvPr id="16" name="Shape 14"/>
           <p:cNvSpPr/>
           <p:nvPr/>
         </p:nvSpPr>
@@ -5963,7 +6250,7 @@
       </p:sp>
       <p:sp>
         <p:nvSpPr>
-          <p:cNvPr id="16" name="Text 14"/>
+          <p:cNvPr id="17" name="Text 15"/>
           <p:cNvSpPr/>
           <p:nvPr/>
         </p:nvSpPr>
@@ -6100,7 +6387,7 @@
       </p:sp>
       <p:sp>
         <p:nvSpPr>
-          <p:cNvPr id="17" name="Text 15"/>
+          <p:cNvPr id="18" name="Text 16"/>
           <p:cNvSpPr/>
           <p:nvPr/>
         </p:nvSpPr>
@@ -6307,6 +6594,47 @@
         </p:nvSpPr>
         <p:spPr>
           <a:xfrm>
+            <a:off x="6766560" y="54864"/>
+            <a:ext cx="2286000" cy="274320"/>
+          </a:xfrm>
+          <a:prstGeom prst="rect">
+            <a:avLst/>
+          </a:prstGeom>
+          <a:noFill/>
+          <a:ln/>
+        </p:spPr>
+        <p:txBody>
+          <a:bodyPr wrap="square" lIns="0" tIns="0" rIns="0" bIns="0" rtlCol="0" anchor="t"/>
+          <a:lstStyle/>
+          <a:p>
+            <a:pPr algn="r" indent="0" marL="0">
+              <a:buNone/>
+            </a:pPr>
+            <a:r>
+              <a:rPr lang="en-US" sz="1000" dirty="0">
+                <a:solidFill>
+                  <a:srgbClr val="CADCFC">
+                    <a:alpha val="75000"/>
+                  </a:srgbClr>
+                </a:solidFill>
+                <a:latin typeface="Consolas" pitchFamily="34" charset="0"/>
+                <a:ea typeface="Consolas" pitchFamily="34" charset="-122"/>
+                <a:cs typeface="Consolas" pitchFamily="34" charset="-120"/>
+              </a:rPr>
+              <a:t>github.com://dzh-a-v</a:t>
+            </a:r>
+            <a:endParaRPr lang="en-US" sz="1000" dirty="0"/>
+          </a:p>
+        </p:txBody>
+      </p:sp>
+      <p:sp>
+        <p:nvSpPr>
+          <p:cNvPr id="7" name="Text 5"/>
+          <p:cNvSpPr/>
+          <p:nvPr/>
+        </p:nvSpPr>
+        <p:spPr>
+          <a:xfrm>
             <a:off x="457200" y="1051560"/>
             <a:ext cx="5120640" cy="292608"/>
           </a:xfrm>
@@ -6340,7 +6668,7 @@
       </p:sp>
       <p:sp>
         <p:nvSpPr>
-          <p:cNvPr id="7" name="Text 5"/>
+          <p:cNvPr id="8" name="Text 6"/>
           <p:cNvSpPr/>
           <p:nvPr/>
         </p:nvSpPr>
@@ -6422,7 +6750,7 @@
       </p:sp>
       <p:sp>
         <p:nvSpPr>
-          <p:cNvPr id="8" name="Text 6"/>
+          <p:cNvPr id="9" name="Text 7"/>
           <p:cNvSpPr/>
           <p:nvPr/>
         </p:nvSpPr>
@@ -6504,7 +6832,7 @@
       </p:sp>
       <p:sp>
         <p:nvSpPr>
-          <p:cNvPr id="9" name="Text 7"/>
+          <p:cNvPr id="10" name="Text 8"/>
           <p:cNvSpPr/>
           <p:nvPr/>
         </p:nvSpPr>
@@ -6586,7 +6914,7 @@
       </p:sp>
       <p:pic>
         <p:nvPicPr>
-          <p:cNvPr id="10" name="Image 0" descr="/home/claude/piecewise/graph4.png">    </p:cNvPr>
+          <p:cNvPr id="11" name="Image 0" descr="/home/claude/piecewise/graph4.png">    </p:cNvPr>
           <p:cNvPicPr>
             <a:picLocks noChangeAspect="1"/>
           </p:cNvPicPr>
@@ -6610,7 +6938,7 @@
       </p:pic>
       <p:sp>
         <p:nvSpPr>
-          <p:cNvPr id="11" name="Shape 8"/>
+          <p:cNvPr id="12" name="Shape 9"/>
           <p:cNvSpPr/>
           <p:nvPr/>
         </p:nvSpPr>
@@ -6635,7 +6963,7 @@
       </p:sp>
       <p:sp>
         <p:nvSpPr>
-          <p:cNvPr id="12" name="Text 9"/>
+          <p:cNvPr id="13" name="Text 10"/>
           <p:cNvSpPr/>
           <p:nvPr/>
         </p:nvSpPr>
@@ -6674,7 +7002,7 @@
       </p:sp>
       <p:sp>
         <p:nvSpPr>
-          <p:cNvPr id="13" name="Text 10"/>
+          <p:cNvPr id="14" name="Text 11"/>
           <p:cNvSpPr/>
           <p:nvPr/>
         </p:nvSpPr>
@@ -6713,7 +7041,7 @@
       </p:sp>
       <p:sp>
         <p:nvSpPr>
-          <p:cNvPr id="14" name="Text 11"/>
+          <p:cNvPr id="15" name="Text 12"/>
           <p:cNvSpPr/>
           <p:nvPr/>
         </p:nvSpPr>

</xml_diff>